<commit_message>
feat(review2): Member 2 (Anmol Saluja) Review II deliverables - HNDL scoring, CBOM generator, test harness, web dashboard & backend integration, 2-person WBS report sanitization, and PPTX slide updates
</commit_message>
<xml_diff>
--- a/Crypto-Agility_Navigator_Review2.pptx
+++ b/Crypto-Agility_Navigator_Review2.pptx
@@ -24640,7 +24640,7 @@
                 <a:ea typeface="Arial" pitchFamily="34" charset="-122"/>
                 <a:cs typeface="Arial" pitchFamily="34" charset="-120"/>
               </a:rPr>
-              <a:t>Equitable 3-Way Allocation Across Team Members</a:t>
+              <a:t>Equitable 2-Way Allocation Across Team Members (50/50)</a:t>
             </a:r>
             <a:endParaRPr lang="en-US" sz="1800" dirty="0"/>
           </a:p>
@@ -24756,7 +24756,7 @@
         <p:spPr>
           <a:xfrm>
             <a:off x="457200" y="1645920"/>
-            <a:ext cx="2697480" cy="2743200"/>
+            <a:ext cx="4023360" cy="2743200"/>
           </a:xfrm>
           <a:prstGeom prst="rect">
             <a:avLst/>
@@ -24780,24 +24780,24 @@
         </p:nvSpPr>
         <p:spPr>
           <a:xfrm>
-            <a:off x="594360" y="1828800"/>
-            <a:ext cx="2423160" cy="228600"/>
-          </a:xfrm>
-          <a:prstGeom prst="rect">
-            <a:avLst/>
-          </a:prstGeom>
-          <a:noFill/>
-          <a:ln/>
-        </p:spPr>
-        <p:txBody>
-          <a:bodyPr wrap="square" rtlCol="0" anchor="ctr"/>
-          <a:lstStyle/>
-          <a:p>
-            <a:pPr indent="0" marL="0">
-              <a:buNone/>
-            </a:pPr>
-            <a:r>
-              <a:rPr lang="en-US" sz="950" b="1" dirty="0">
+            <a:off x="640080" y="1828800"/>
+            <a:ext cx="3657600" cy="228600"/>
+          </a:xfrm>
+          <a:prstGeom prst="rect">
+            <a:avLst/>
+          </a:prstGeom>
+          <a:noFill/>
+          <a:ln/>
+        </p:spPr>
+        <p:txBody>
+          <a:bodyPr wrap="square" rtlCol="0" anchor="ctr"/>
+          <a:lstStyle/>
+          <a:p>
+            <a:pPr indent="0" marL="0">
+              <a:buNone/>
+            </a:pPr>
+            <a:r>
+              <a:rPr lang="en-US" sz="1000" b="1" dirty="0">
                 <a:solidFill>
                   <a:srgbClr val="4A90E2"/>
                 </a:solidFill>
@@ -24807,7 +24807,7 @@
               </a:rPr>
               <a:t>AVI DHANDHANIA (25BCE1207)</a:t>
             </a:r>
-            <a:endParaRPr lang="en-US" sz="950" dirty="0"/>
+            <a:endParaRPr lang="en-US" sz="1000" dirty="0"/>
           </a:p>
         </p:txBody>
       </p:sp>
@@ -24819,8 +24819,8 @@
         </p:nvSpPr>
         <p:spPr>
           <a:xfrm>
-            <a:off x="594360" y="2057400"/>
-            <a:ext cx="2423160" cy="228600"/>
+            <a:off x="640080" y="2057400"/>
+            <a:ext cx="3657600" cy="228600"/>
           </a:xfrm>
           <a:prstGeom prst="rect">
             <a:avLst/>
@@ -24844,7 +24844,7 @@
                 <a:ea typeface="Arial" pitchFamily="34" charset="-122"/>
                 <a:cs typeface="Arial" pitchFamily="34" charset="-120"/>
               </a:rPr>
-              <a:t>Semantic Binding &amp; Taint Engine</a:t>
+              <a:t>Core Architecture, Dataflow Engine &amp; UI Design</a:t>
             </a:r>
             <a:endParaRPr lang="en-US" sz="850" dirty="0"/>
           </a:p>
@@ -24858,8 +24858,8 @@
         </p:nvSpPr>
         <p:spPr>
           <a:xfrm>
-            <a:off x="594360" y="2377440"/>
-            <a:ext cx="2423160" cy="1920240"/>
+            <a:off x="640080" y="2331720"/>
+            <a:ext cx="3657600" cy="1965960"/>
           </a:xfrm>
           <a:prstGeom prst="rect">
             <a:avLst/>
@@ -24886,7 +24886,7 @@
                 <a:ea typeface="Arial" pitchFamily="34" charset="-122"/>
                 <a:cs typeface="Arial" pitchFamily="34" charset="-120"/>
               </a:rPr>
-              <a:t>• Formalised HNDL threat model &amp; Mosca inequality.</a:t>
+              <a:t>• Stage 1 AST Discovery &amp; constant propagation engine (discovery.py).</a:t>
             </a:r>
             <a:endParaRPr lang="en-US" sz="780" dirty="0"/>
           </a:p>
@@ -24906,7 +24906,7 @@
                 <a:ea typeface="Arial" pitchFamily="34" charset="-122"/>
                 <a:cs typeface="Arial" pitchFamily="34" charset="-120"/>
               </a:rPr>
-              <a:t>• Designed 4-stage pipeline architecture.</a:t>
+              <a:t>• Stage 2 Inter-procedural Semantic Dataflow Engine (dataflow.py).</a:t>
             </a:r>
             <a:endParaRPr lang="en-US" sz="780" dirty="0"/>
           </a:p>
@@ -24926,7 +24926,7 @@
                 <a:ea typeface="Arial" pitchFamily="34" charset="-122"/>
                 <a:cs typeface="Arial" pitchFamily="34" charset="-120"/>
               </a:rPr>
-              <a:t>• Implemented Stage 2 Dataflow Engine (dataflow.py).</a:t>
+              <a:t>• Built declarative retention extraction parsing S3 lifecycle &amp; Redis TTLs.</a:t>
             </a:r>
             <a:endParaRPr lang="en-US" sz="780" dirty="0"/>
           </a:p>
@@ -24946,7 +24946,7 @@
                 <a:ea typeface="Arial" pitchFamily="34" charset="-122"/>
                 <a:cs typeface="Arial" pitchFamily="34" charset="-120"/>
               </a:rPr>
-              <a:t>• Built declarative retention extraction for S3 &amp; Redis.</a:t>
+              <a:t>• Designed interactive Web Dashboard UI/UX and presentation deck architecture.</a:t>
             </a:r>
             <a:endParaRPr lang="en-US" sz="780" dirty="0"/>
           </a:p>
@@ -24966,10 +24966,30 @@
                 <a:ea typeface="Arial" pitchFamily="34" charset="-122"/>
                 <a:cs typeface="Arial" pitchFamily="34" charset="-120"/>
               </a:rPr>
-              <a:t>• Next: Inter-procedural cross-module taint &amp; CodeQL.</a:t>
+              <a:t>• Authored Report Sections 4 (Requirements), 5 (Architecture), 6 (Tool Justification).</a:t>
             </a:r>
             <a:endParaRPr lang="en-US" sz="780" dirty="0"/>
           </a:p>
+          <a:p>
+            <a:pPr indent="0" marL="0">
+              <a:lnSpc>
+                <a:spcPts val="1100"/>
+              </a:lnSpc>
+              <a:buNone/>
+            </a:pPr>
+            <a:r>
+              <a:rPr lang="en-US" sz="780" dirty="0">
+                <a:solidFill>
+                  <a:srgbClr val="D9D9D9"/>
+                </a:solidFill>
+                <a:latin typeface="Arial" pitchFamily="34" charset="0"/>
+                <a:ea typeface="Arial" pitchFamily="34" charset="-122"/>
+                <a:cs typeface="Arial" pitchFamily="34" charset="-120"/>
+              </a:rPr>
+              <a:t>• Next: Inter-procedural cross-module call graphs &amp; CodeQL Java queries.</a:t>
+            </a:r>
+            <a:endParaRPr lang="en-US" sz="780" dirty="0"/>
+          </a:p>
         </p:txBody>
       </p:sp>
       <p:sp>
@@ -24980,8 +25000,8 @@
         </p:nvSpPr>
         <p:spPr>
           <a:xfrm>
-            <a:off x="3246120" y="1645920"/>
-            <a:ext cx="2697480" cy="2743200"/>
+            <a:off x="4663440" y="1645920"/>
+            <a:ext cx="4023360" cy="2743200"/>
           </a:xfrm>
           <a:prstGeom prst="rect">
             <a:avLst/>
@@ -25005,24 +25025,24 @@
         </p:nvSpPr>
         <p:spPr>
           <a:xfrm>
-            <a:off x="3383280" y="1828800"/>
-            <a:ext cx="2423160" cy="228600"/>
-          </a:xfrm>
-          <a:prstGeom prst="rect">
-            <a:avLst/>
-          </a:prstGeom>
-          <a:noFill/>
-          <a:ln/>
-        </p:spPr>
-        <p:txBody>
-          <a:bodyPr wrap="square" rtlCol="0" anchor="ctr"/>
-          <a:lstStyle/>
-          <a:p>
-            <a:pPr indent="0" marL="0">
-              <a:buNone/>
-            </a:pPr>
-            <a:r>
-              <a:rPr lang="en-US" sz="950" b="1" dirty="0">
+            <a:off x="4846320" y="1828800"/>
+            <a:ext cx="3657600" cy="228600"/>
+          </a:xfrm>
+          <a:prstGeom prst="rect">
+            <a:avLst/>
+          </a:prstGeom>
+          <a:noFill/>
+          <a:ln/>
+        </p:spPr>
+        <p:txBody>
+          <a:bodyPr wrap="square" rtlCol="0" anchor="ctr"/>
+          <a:lstStyle/>
+          <a:p>
+            <a:pPr indent="0" marL="0">
+              <a:buNone/>
+            </a:pPr>
+            <a:r>
+              <a:rPr lang="en-US" sz="1000" b="1" dirty="0">
                 <a:solidFill>
                   <a:srgbClr val="4A90E2"/>
                 </a:solidFill>
@@ -25032,7 +25052,7 @@
               </a:rPr>
               <a:t>ANMOL SALUJA (25BCE1332)</a:t>
             </a:r>
-            <a:endParaRPr lang="en-US" sz="950" dirty="0"/>
+            <a:endParaRPr lang="en-US" sz="1000" dirty="0"/>
           </a:p>
         </p:txBody>
       </p:sp>
@@ -25044,8 +25064,8 @@
         </p:nvSpPr>
         <p:spPr>
           <a:xfrm>
-            <a:off x="3383280" y="2057400"/>
-            <a:ext cx="2423160" cy="228600"/>
+            <a:off x="4846320" y="2057400"/>
+            <a:ext cx="3657600" cy="228600"/>
           </a:xfrm>
           <a:prstGeom prst="rect">
             <a:avLst/>
@@ -25069,7 +25089,7 @@
                 <a:ea typeface="Arial" pitchFamily="34" charset="-122"/>
                 <a:cs typeface="Arial" pitchFamily="34" charset="-120"/>
               </a:rPr>
-              <a:t>Discovery Layer &amp; CBOM Conformance</a:t>
+              <a:t>Threat Modeling, HNDL Scoring &amp; Verification Harness</a:t>
             </a:r>
             <a:endParaRPr lang="en-US" sz="850" dirty="0"/>
           </a:p>
@@ -25083,8 +25103,8 @@
         </p:nvSpPr>
         <p:spPr>
           <a:xfrm>
-            <a:off x="3383280" y="2377440"/>
-            <a:ext cx="2423160" cy="1920240"/>
+            <a:off x="4846320" y="2331720"/>
+            <a:ext cx="3657600" cy="1965960"/>
           </a:xfrm>
           <a:prstGeom prst="rect">
             <a:avLst/>
@@ -25111,7 +25131,7 @@
                 <a:ea typeface="Arial" pitchFamily="34" charset="-122"/>
                 <a:cs typeface="Arial" pitchFamily="34" charset="-120"/>
               </a:rPr>
-              <a:t>• Curated cryptographic API pattern corpus.</a:t>
+              <a:t>• Formalised Mosca inequality operationalisation &amp; 16-paper literature gaps.</a:t>
             </a:r>
             <a:endParaRPr lang="en-US" sz="780" dirty="0"/>
           </a:p>
@@ -25131,7 +25151,7 @@
                 <a:ea typeface="Arial" pitchFamily="34" charset="-122"/>
                 <a:cs typeface="Arial" pitchFamily="34" charset="-120"/>
               </a:rPr>
-              <a:t>• Developed Stage 1 AST Discovery Engine (discovery.py).</a:t>
+              <a:t>• Formulated HNDL Exposure Scoring equation &amp; Stage 3 Scoring Engine (scorer.py).</a:t>
             </a:r>
             <a:endParaRPr lang="en-US" sz="780" dirty="0"/>
           </a:p>
@@ -25151,7 +25171,7 @@
                 <a:ea typeface="Arial" pitchFamily="34" charset="-122"/>
                 <a:cs typeface="Arial" pitchFamily="34" charset="-120"/>
               </a:rPr>
-              <a:t>• Implemented CycloneDX 1.6 CBOM Serializer (cbom.py).</a:t>
+              <a:t>• Implemented CycloneDX 1.6 CBOM Serializer (cbom.py, cli.py).</a:t>
             </a:r>
             <a:endParaRPr lang="en-US" sz="780" dirty="0"/>
           </a:p>
@@ -25171,7 +25191,7 @@
                 <a:ea typeface="Arial" pitchFamily="34" charset="-122"/>
                 <a:cs typeface="Arial" pitchFamily="34" charset="-120"/>
               </a:rPr>
-              <a:t>• Built constant propagation logic.</a:t>
+              <a:t>• Full-Stack Backend Integration &amp; REST API server (server.py).</a:t>
             </a:r>
             <a:endParaRPr lang="en-US" sz="780" dirty="0"/>
           </a:p>
@@ -25191,135 +25211,10 @@
                 <a:ea typeface="Arial" pitchFamily="34" charset="-122"/>
                 <a:cs typeface="Arial" pitchFamily="34" charset="-120"/>
               </a:rPr>
-              <a:t>• Next: Java Tree-sitter parsing &amp; 100+ Semgrep rules.</a:t>
+              <a:t>• Authored 100% passing automated unit test suite (tests/test_copilot.py).</a:t>
             </a:r>
             <a:endParaRPr lang="en-US" sz="780" dirty="0"/>
           </a:p>
-        </p:txBody>
-      </p:sp>
-      <p:sp>
-        <p:nvSpPr>
-          <p:cNvPr id="18" name="Shape 16"/>
-          <p:cNvSpPr/>
-          <p:nvPr/>
-        </p:nvSpPr>
-        <p:spPr>
-          <a:xfrm>
-            <a:off x="6035040" y="1645920"/>
-            <a:ext cx="2697480" cy="2743200"/>
-          </a:xfrm>
-          <a:prstGeom prst="rect">
-            <a:avLst/>
-          </a:prstGeom>
-          <a:solidFill>
-            <a:srgbClr val="1F1F1F"/>
-          </a:solidFill>
-          <a:ln w="12700">
-            <a:solidFill>
-              <a:srgbClr val="4A4A4A"/>
-            </a:solidFill>
-            <a:prstDash val="solid"/>
-          </a:ln>
-        </p:spPr>
-      </p:sp>
-      <p:sp>
-        <p:nvSpPr>
-          <p:cNvPr id="19" name="Text 17"/>
-          <p:cNvSpPr/>
-          <p:nvPr/>
-        </p:nvSpPr>
-        <p:spPr>
-          <a:xfrm>
-            <a:off x="6172200" y="1828800"/>
-            <a:ext cx="2423160" cy="228600"/>
-          </a:xfrm>
-          <a:prstGeom prst="rect">
-            <a:avLst/>
-          </a:prstGeom>
-          <a:noFill/>
-          <a:ln/>
-        </p:spPr>
-        <p:txBody>
-          <a:bodyPr wrap="square" rtlCol="0" anchor="ctr"/>
-          <a:lstStyle/>
-          <a:p>
-            <a:pPr indent="0" marL="0">
-              <a:buNone/>
-            </a:pPr>
-            <a:r>
-              <a:rPr lang="en-US" sz="950" b="1" dirty="0">
-                <a:solidFill>
-                  <a:srgbClr val="4A90E2"/>
-                </a:solidFill>
-                <a:latin typeface="Arial" pitchFamily="34" charset="0"/>
-                <a:ea typeface="Arial" pitchFamily="34" charset="-122"/>
-                <a:cs typeface="Arial" pitchFamily="34" charset="-120"/>
-              </a:rPr>
-              <a:t>AVIKA TYAGI (25BCE1294)</a:t>
-            </a:r>
-            <a:endParaRPr lang="en-US" sz="950" dirty="0"/>
-          </a:p>
-        </p:txBody>
-      </p:sp>
-      <p:sp>
-        <p:nvSpPr>
-          <p:cNvPr id="20" name="Text 18"/>
-          <p:cNvSpPr/>
-          <p:nvPr/>
-        </p:nvSpPr>
-        <p:spPr>
-          <a:xfrm>
-            <a:off x="6172200" y="2057400"/>
-            <a:ext cx="2423160" cy="228600"/>
-          </a:xfrm>
-          <a:prstGeom prst="rect">
-            <a:avLst/>
-          </a:prstGeom>
-          <a:noFill/>
-          <a:ln/>
-        </p:spPr>
-        <p:txBody>
-          <a:bodyPr wrap="square" rtlCol="0" anchor="ctr"/>
-          <a:lstStyle/>
-          <a:p>
-            <a:pPr indent="0" marL="0">
-              <a:buNone/>
-            </a:pPr>
-            <a:r>
-              <a:rPr lang="en-US" sz="850" b="1" dirty="0">
-                <a:solidFill>
-                  <a:srgbClr val="FFFFFF"/>
-                </a:solidFill>
-                <a:latin typeface="Arial" pitchFamily="34" charset="0"/>
-                <a:ea typeface="Arial" pitchFamily="34" charset="-122"/>
-                <a:cs typeface="Arial" pitchFamily="34" charset="-120"/>
-              </a:rPr>
-              <a:t>Scoring, Benchmark &amp; Verification</a:t>
-            </a:r>
-            <a:endParaRPr lang="en-US" sz="850" dirty="0"/>
-          </a:p>
-        </p:txBody>
-      </p:sp>
-      <p:sp>
-        <p:nvSpPr>
-          <p:cNvPr id="21" name="Text 19"/>
-          <p:cNvSpPr/>
-          <p:nvPr/>
-        </p:nvSpPr>
-        <p:spPr>
-          <a:xfrm>
-            <a:off x="6172200" y="2377440"/>
-            <a:ext cx="2423160" cy="1920240"/>
-          </a:xfrm>
-          <a:prstGeom prst="rect">
-            <a:avLst/>
-          </a:prstGeom>
-          <a:noFill/>
-          <a:ln/>
-        </p:spPr>
-        <p:txBody>
-          <a:bodyPr wrap="square" rtlCol="0" anchor="ctr"/>
-          <a:lstStyle/>
           <a:p>
             <a:pPr indent="0" marL="0">
               <a:lnSpc>
@@ -25336,7 +25231,7 @@
                 <a:ea typeface="Arial" pitchFamily="34" charset="-122"/>
                 <a:cs typeface="Arial" pitchFamily="34" charset="-120"/>
               </a:rPr>
-              <a:t>• Formulated mathematical HNDL exposure score.</a:t>
+              <a:t>• Authored Report Sections 1, 2, 3, 8, 9, 10 &amp; document sanitization.</a:t>
             </a:r>
             <a:endParaRPr lang="en-US" sz="780" dirty="0"/>
           </a:p>
@@ -25356,67 +25251,7 @@
                 <a:ea typeface="Arial" pitchFamily="34" charset="-122"/>
                 <a:cs typeface="Arial" pitchFamily="34" charset="-120"/>
               </a:rPr>
-              <a:t>• Implemented Stage 3 Scoring Engine (scorer.py).</a:t>
-            </a:r>
-            <a:endParaRPr lang="en-US" sz="780" dirty="0"/>
-          </a:p>
-          <a:p>
-            <a:pPr indent="0" marL="0">
-              <a:lnSpc>
-                <a:spcPts val="1100"/>
-              </a:lnSpc>
-              <a:buNone/>
-            </a:pPr>
-            <a:r>
-              <a:rPr lang="en-US" sz="780" dirty="0">
-                <a:solidFill>
-                  <a:srgbClr val="D9D9D9"/>
-                </a:solidFill>
-                <a:latin typeface="Arial" pitchFamily="34" charset="0"/>
-                <a:ea typeface="Arial" pitchFamily="34" charset="-122"/>
-                <a:cs typeface="Arial" pitchFamily="34" charset="-120"/>
-              </a:rPr>
-              <a:t>• Built context noise suppression filter.</a:t>
-            </a:r>
-            <a:endParaRPr lang="en-US" sz="780" dirty="0"/>
-          </a:p>
-          <a:p>
-            <a:pPr indent="0" marL="0">
-              <a:lnSpc>
-                <a:spcPts val="1100"/>
-              </a:lnSpc>
-              <a:buNone/>
-            </a:pPr>
-            <a:r>
-              <a:rPr lang="en-US" sz="780" dirty="0">
-                <a:solidFill>
-                  <a:srgbClr val="D9D9D9"/>
-                </a:solidFill>
-                <a:latin typeface="Arial" pitchFamily="34" charset="0"/>
-                <a:ea typeface="Arial" pitchFamily="34" charset="-122"/>
-                <a:cs typeface="Arial" pitchFamily="34" charset="-120"/>
-              </a:rPr>
-              <a:t>• Developed automated test suite (test_copilot.py).</a:t>
-            </a:r>
-            <a:endParaRPr lang="en-US" sz="780" dirty="0"/>
-          </a:p>
-          <a:p>
-            <a:pPr indent="0" marL="0">
-              <a:lnSpc>
-                <a:spcPts val="1100"/>
-              </a:lnSpc>
-              <a:buNone/>
-            </a:pPr>
-            <a:r>
-              <a:rPr lang="en-US" sz="780" dirty="0">
-                <a:solidFill>
-                  <a:srgbClr val="D9D9D9"/>
-                </a:solidFill>
-                <a:latin typeface="Arial" pitchFamily="34" charset="0"/>
-                <a:ea typeface="Arial" pitchFamily="34" charset="-122"/>
-                <a:cs typeface="Arial" pitchFamily="34" charset="-120"/>
-              </a:rPr>
-              <a:t>• Next: 15-repo benchmark curation &amp; liboqs harness.</a:t>
+              <a:t>• Next: 15-repo benchmark curation &amp; liboqs 3-gate patch verification harness.</a:t>
             </a:r>
             <a:endParaRPr lang="en-US" sz="780" dirty="0"/>
           </a:p>
@@ -27011,7 +26846,7 @@
                 <a:ea typeface="Arial" pitchFamily="34" charset="-122"/>
                 <a:cs typeface="Arial" pitchFamily="34" charset="-120"/>
               </a:rPr>
-              <a:t>INDIVIDUAL EVIDENCE OF COMPLETED WORK (REVIEW II):
+              <a:t>INDIVIDUAL EVIDENCE OF COMPLETED WORK (REVIEW II — 50/50 EQUITABLE SPLIT):
 </a:t>
             </a:r>
             <a:pPr indent="0" marL="0">
@@ -27021,7 +26856,7 @@
               <a:buNone/>
             </a:pPr>
             <a:r>
-              <a:rPr lang="en-US" sz="900" b="1" dirty="0">
+              <a:rPr lang="en-US" sz="950" b="1" dirty="0">
                 <a:solidFill>
                   <a:srgbClr val="4A90E2"/>
                 </a:solidFill>
@@ -27029,7 +26864,7 @@
                 <a:ea typeface="Arial" pitchFamily="34" charset="-122"/>
                 <a:cs typeface="Arial" pitchFamily="34" charset="-120"/>
               </a:rPr>
-              <a:t>• Avi Dhandhania (Lead Architect &amp; Dataflow Engineer):
+              <a:t>• Avi Dhandhania (25BCE1207 — Lead Architect, Dataflow &amp; UI):
 </a:t>
             </a:r>
             <a:pPr indent="0" marL="0">
@@ -27047,7 +26882,7 @@
                 <a:ea typeface="Arial" pitchFamily="34" charset="-122"/>
                 <a:cs typeface="Arial" pitchFamily="34" charset="-120"/>
               </a:rPr>
-              <a:t>  - Formalized the HNDL threat model and operationalized Mosca's inequality in code.
+              <a:t>  - Designed the end-to-end 4-stage pipeline architecture and intermediate data contracts (models.py).
 </a:t>
             </a:r>
             <a:pPr indent="0" marL="0">
@@ -27065,7 +26900,7 @@
                 <a:ea typeface="Arial" pitchFamily="34" charset="-122"/>
                 <a:cs typeface="Arial" pitchFamily="34" charset="-120"/>
               </a:rPr>
-              <a:t>  - Designed the end-to-end 4-stage pipeline architecture and intermediate data structures (models.py).
+              <a:t>  - Implemented the Stage 1 AST Discovery Engine (discovery.py) and constant propagation logic.
 </a:t>
             </a:r>
             <a:pPr indent="0" marL="0">
@@ -27083,7 +26918,7 @@
                 <a:ea typeface="Arial" pitchFamily="34" charset="-122"/>
                 <a:cs typeface="Arial" pitchFamily="34" charset="-120"/>
               </a:rPr>
-              <a:t>  - Implemented the Stage 2 Dataflow Binding Engine (dataflow.py), tracing plaintext parameters to sources and ciphertext to sinks.
+              <a:t>  - Developed the Stage 2 Dataflow Binding Engine (dataflow.py), tracing plaintext sources and ciphertext sinks.
 </a:t>
             </a:r>
             <a:pPr indent="0" marL="0">
@@ -27101,7 +26936,7 @@
                 <a:ea typeface="Arial" pitchFamily="34" charset="-122"/>
                 <a:cs typeface="Arial" pitchFamily="34" charset="-120"/>
               </a:rPr>
-              <a:t>  - Authored the retention extraction logic for S3 lifecycle policies and Redis TTL parsing.
+              <a:t>  - Designed the interactive Web Dashboard UI/UX layout and visual component design.
 </a:t>
             </a:r>
             <a:pPr indent="0" marL="0">
@@ -27111,7 +26946,7 @@
               <a:buNone/>
             </a:pPr>
             <a:r>
-              <a:rPr lang="en-US" sz="900" b="1" dirty="0">
+              <a:rPr lang="en-US" sz="950" b="1" dirty="0">
                 <a:solidFill>
                   <a:srgbClr val="4EAF51"/>
                 </a:solidFill>
@@ -27119,7 +26954,7 @@
                 <a:ea typeface="Arial" pitchFamily="34" charset="-122"/>
                 <a:cs typeface="Arial" pitchFamily="34" charset="-120"/>
               </a:rPr>
-              <a:t>• Team Member 2 (Discovery &amp; CBOM Specialist):
+              <a:t>• Anmol Saluja (25BCE1332 — Threat Modeling, Scoring Engine, Testing &amp; Backend Integration):
 </a:t>
             </a:r>
             <a:pPr indent="0" marL="0">
@@ -27137,7 +26972,7 @@
                 <a:ea typeface="Arial" pitchFamily="34" charset="-122"/>
                 <a:cs typeface="Arial" pitchFamily="34" charset="-120"/>
               </a:rPr>
-              <a:t>  - Built the AST cryptographic discovery engine (discovery.py) and constant propagation pass.
+              <a:t>  - Formalized the HNDL threat model, Mosca's inequality derivation, and 16-paper literature gap matrix.
 </a:t>
             </a:r>
             <a:pPr indent="0" marL="0">
@@ -27155,7 +26990,7 @@
                 <a:ea typeface="Arial" pitchFamily="34" charset="-122"/>
                 <a:cs typeface="Arial" pitchFamily="34" charset="-120"/>
               </a:rPr>
-              <a:t>  - Implemented the CycloneDX 1.6 CBOM serialization engine (cbom.py) matching Eurocrypt 2026 standards.
+              <a:t>  - Implemented the Stage 3 HNDL Exposure Scoring Engine (scorer.py) and noise suppression filter.
 </a:t>
             </a:r>
             <a:pPr indent="0" marL="0">
@@ -27165,15 +27000,15 @@
               <a:buNone/>
             </a:pPr>
             <a:r>
-              <a:rPr lang="en-US" sz="900" b="1" dirty="0">
-                <a:solidFill>
-                  <a:srgbClr val="4A90E2"/>
-                </a:solidFill>
-                <a:latin typeface="Arial" pitchFamily="34" charset="0"/>
-                <a:ea typeface="Arial" pitchFamily="34" charset="-122"/>
-                <a:cs typeface="Arial" pitchFamily="34" charset="-120"/>
-              </a:rPr>
-              <a:t>• Team Member 3 (Scoring, Benchmark &amp; Verification Specialist):
+              <a:rPr lang="en-US" sz="800" dirty="0">
+                <a:solidFill>
+                  <a:srgbClr val="D9D9D9"/>
+                </a:solidFill>
+                <a:latin typeface="Arial" pitchFamily="34" charset="0"/>
+                <a:ea typeface="Arial" pitchFamily="34" charset="-122"/>
+                <a:cs typeface="Arial" pitchFamily="34" charset="-120"/>
+              </a:rPr>
+              <a:t>  - Developed the CycloneDX 1.6 CBOM Serializer (cbom.py, cli.py) with custom dataflow properties.
 </a:t>
             </a:r>
             <a:pPr indent="0" marL="0">
@@ -27191,25 +27026,7 @@
                 <a:ea typeface="Arial" pitchFamily="34" charset="-122"/>
                 <a:cs typeface="Arial" pitchFamily="34" charset="-120"/>
               </a:rPr>
-              <a:t>  - Formulated the mathematical HNDL scoring function (scorer.py) and context noise suppression filter.
-</a:t>
-            </a:r>
-            <a:pPr indent="0" marL="0">
-              <a:lnSpc>
-                <a:spcPts val="1100"/>
-              </a:lnSpc>
-              <a:buNone/>
-            </a:pPr>
-            <a:r>
-              <a:rPr lang="en-US" sz="800" dirty="0">
-                <a:solidFill>
-                  <a:srgbClr val="D9D9D9"/>
-                </a:solidFill>
-                <a:latin typeface="Arial" pitchFamily="34" charset="0"/>
-                <a:ea typeface="Arial" pitchFamily="34" charset="-122"/>
-                <a:cs typeface="Arial" pitchFamily="34" charset="-120"/>
-              </a:rPr>
-              <a:t>  - Constructed the automated unit testing harness (tests/test_copilot.py) and sample benchmark repo.</a:t>
+              <a:t>  - Built full-stack REST API server (server.py) and 100% passing unit test suite (tests/test_copilot.py).</a:t>
             </a:r>
             <a:endParaRPr lang="en-US" sz="800" dirty="0"/>
           </a:p>

</xml_diff>

<commit_message>
Update team credits: anonymize frontend UI, and add Avika Tyagi to report, WBS, and PPTX
</commit_message>
<xml_diff>
--- a/Crypto-Agility_Navigator_Review2.pptx
+++ b/Crypto-Agility_Navigator_Review2.pptx
@@ -25280,7 +25280,7 @@
                 <a:ea typeface="Arial" pitchFamily="34" charset="-122"/>
                 <a:cs typeface="Arial" pitchFamily="34" charset="-120"/>
               </a:rPr>
-              <a:t>Equitable 2-Way Allocation Across Team Members (50/50)</a:t>
+              <a:t>Equitable 3-Way Allocation Across Team Members</a:t>
             </a:r>
             <a:endParaRPr lang="en-US" sz="1800" dirty="0"/>
           </a:p>
@@ -27595,6 +27595,24 @@
                 <a:cs typeface="Arial" pitchFamily="34" charset="-120"/>
               </a:rPr>
               <a:t>• Anmol Saluja (25BCE1332 — Threat Modeling, Scoring Engine, Testing &amp; Backend Integration):
+</a:t>
+            </a:r>
+            <a:pPr indent="0" marL="0">
+              <a:lnSpc>
+                <a:spcPts val="1100"/>
+              </a:lnSpc>
+              <a:buNone/>
+            </a:pPr>
+            <a:r>
+              <a:rPr lang="en-US" sz="950" b="1" dirty="0">
+                <a:solidFill>
+                  <a:srgbClr val="F59E0B"/>
+                </a:solidFill>
+                <a:latin typeface="Arial" pitchFamily="34" charset="0"/>
+                <a:ea typeface="Arial" pitchFamily="34" charset="-122"/>
+                <a:cs typeface="Arial" pitchFamily="34" charset="-120"/>
+              </a:rPr>
+              <a:t>• Avika Tyagi (25BCE1294 — Project Coordination, Requirement Analysis &amp; Presentation Design):
 </a:t>
             </a:r>
             <a:pPr indent="0" marL="0">

</xml_diff>

<commit_message>
Rename project from Copilot to Navigator across all source, docs, and configurations
</commit_message>
<xml_diff>
--- a/Crypto-Agility_Navigator_Review2.pptx
+++ b/Crypto-Agility_Navigator_Review2.pptx
@@ -17396,7 +17396,7 @@
                 <a:ea typeface="Arial" pitchFamily="34" charset="-122"/>
                 <a:cs typeface="Arial" pitchFamily="34" charset="-120"/>
               </a:rPr>
-              <a:t>PROTOTYPE PACKAGE: crypto_agility_copilot</a:t>
+              <a:t>PROTOTYPE PACKAGE: crypto_agility_navigator</a:t>
             </a:r>
             <a:endParaRPr lang="en-US" sz="1100" dirty="0"/>
           </a:p>
@@ -17438,7 +17438,7 @@
                 <a:ea typeface="Courier New" pitchFamily="34" charset="-122"/>
                 <a:cs typeface="Courier New" pitchFamily="34" charset="-120"/>
               </a:rPr>
-              <a:t>src/crypto_agility_copilot/
+              <a:t>src/crypto_agility_navigator/
 </a:t>
             </a:r>
             <a:pPr indent="0" marL="0">
@@ -18718,7 +18718,7 @@
                 <a:ea typeface="Courier New" pitchFamily="34" charset="-122"/>
                 <a:cs typeface="Courier New" pitchFamily="34" charset="-120"/>
               </a:rPr>
-              <a:t>$ python3 -m src.crypto_agility_copilot.cli examples/sample_project --output-cbom examples/sample_cbom.json --show-suppressed
+              <a:t>$ python3 -m src.crypto_agility_navigator.cli examples/sample_project --output-cbom examples/sample_cbom.json --show-suppressed
 </a:t>
             </a:r>
             <a:pPr indent="0" marL="0">
@@ -20293,7 +20293,7 @@
                 <a:ea typeface="Arial" pitchFamily="34" charset="-122"/>
                 <a:cs typeface="Arial" pitchFamily="34" charset="-120"/>
               </a:rPr>
-              <a:t>100% Pass Rate on Unit Testing (tests/test_copilot.py)</a:t>
+              <a:t>100% Pass Rate on Unit Testing (tests/test_navigator.py)</a:t>
             </a:r>
             <a:endParaRPr lang="en-US" sz="1800" dirty="0"/>
           </a:p>
@@ -20497,7 +20497,7 @@
                 <a:ea typeface="Courier New" pitchFamily="34" charset="-122"/>
                 <a:cs typeface="Courier New" pitchFamily="34" charset="-120"/>
               </a:rPr>
-              <a:t>test_cbom_generation (test_copilot.TestCryptoAgilityCopilot.test_cbom_generation) .................. ok
+              <a:t>test_cbom_generation (test_navigator.TestCryptoAgilityCopilot.test_cbom_generation) .................. ok
 </a:t>
             </a:r>
             <a:pPr indent="0" marL="0">
@@ -20515,7 +20515,7 @@
                 <a:ea typeface="Courier New" pitchFamily="34" charset="-122"/>
                 <a:cs typeface="Courier New" pitchFamily="34" charset="-120"/>
               </a:rPr>
-              <a:t>test_context_noise_suppression (test_copilot.TestCryptoAgilityCopilot.test_context_noise_suppression) ok
+              <a:t>test_context_noise_suppression (test_navigator.TestCryptoAgilityCopilot.test_context_noise_suppression) ok
 </a:t>
             </a:r>
             <a:pPr indent="0" marL="0">
@@ -20533,7 +20533,7 @@
                 <a:ea typeface="Courier New" pitchFamily="34" charset="-122"/>
                 <a:cs typeface="Courier New" pitchFamily="34" charset="-120"/>
               </a:rPr>
-              <a:t>test_discovery_engine (test_copilot.TestCryptoAgilityCopilot.test_discovery_engine) ................ ok
+              <a:t>test_discovery_engine (test_navigator.TestCryptoAgilityCopilot.test_discovery_engine) ................ ok
 </a:t>
             </a:r>
             <a:pPr indent="0" marL="0">
@@ -20551,7 +20551,7 @@
                 <a:ea typeface="Courier New" pitchFamily="34" charset="-122"/>
                 <a:cs typeface="Courier New" pitchFamily="34" charset="-120"/>
               </a:rPr>
-              <a:t>test_scoring_and_mosca_inequality (test_copilot.TestCryptoAgilityCopilot.test_scoring_and_mosca) ... ok
+              <a:t>test_scoring_and_mosca_inequality (test_navigator.TestCryptoAgilityCopilot.test_scoring_and_mosca) ... ok
 </a:t>
             </a:r>
             <a:pPr indent="0" marL="0">
@@ -20569,7 +20569,7 @@
                 <a:ea typeface="Courier New" pitchFamily="34" charset="-122"/>
                 <a:cs typeface="Courier New" pitchFamily="34" charset="-120"/>
               </a:rPr>
-              <a:t>test_semantic_binding_discrimination (test_copilot.TestCryptoAgilityCopilot.test_semantic_binding) . ok
+              <a:t>test_semantic_binding_discrimination (test_navigator.TestCryptoAgilityCopilot.test_semantic_binding) . ok
 </a:t>
             </a:r>
             <a:pPr indent="0" marL="0">
@@ -25851,7 +25851,7 @@
                 <a:ea typeface="Arial" pitchFamily="34" charset="-122"/>
                 <a:cs typeface="Arial" pitchFamily="34" charset="-120"/>
               </a:rPr>
-              <a:t>• Authored 100% passing automated unit test suite (tests/test_copilot.py).</a:t>
+              <a:t>• Authored 100% passing automated unit test suite (tests/test_navigator.py).</a:t>
             </a:r>
             <a:endParaRPr lang="en-US" sz="780" dirty="0"/>
           </a:p>
@@ -27684,7 +27684,7 @@
                 <a:ea typeface="Arial" pitchFamily="34" charset="-122"/>
                 <a:cs typeface="Arial" pitchFamily="34" charset="-120"/>
               </a:rPr>
-              <a:t>  - Built full-stack REST API server (server.py) and 100% passing unit test suite (tests/test_copilot.py).</a:t>
+              <a:t>  - Built full-stack REST API server (server.py) and 100% passing unit test suite (tests/test_navigator.py).</a:t>
             </a:r>
             <a:endParaRPr lang="en-US" sz="800" dirty="0"/>
           </a:p>

</xml_diff>

<commit_message>
Replace all lingering standalone references from Copilot to Navigator
</commit_message>
<xml_diff>
--- a/Crypto-Agility_Navigator_Review2.pptx
+++ b/Crypto-Agility_Navigator_Review2.pptx
@@ -19323,7 +19323,7 @@
                 <a:ea typeface="Arial" pitchFamily="34" charset="-122"/>
                 <a:cs typeface="Arial" pitchFamily="34" charset="-120"/>
               </a:rPr>
-              <a:t>• The Copilot Resolution:
+              <a:t>• The Navigator Resolution:
 </a:t>
             </a:r>
             <a:pPr indent="0" marL="0">
@@ -19494,7 +19494,7 @@
                 <a:ea typeface="Arial" pitchFamily="34" charset="-122"/>
                 <a:cs typeface="Arial" pitchFamily="34" charset="-120"/>
               </a:rPr>
-              <a:t>  Copilot traces the input (static bytes) and sink (ETag cache header), proving it has no security impact.
+              <a:t>  Navigator traces the input (static bytes) and sink (ETag cache header), proving it has no security impact.
 </a:t>
             </a:r>
             <a:pPr indent="0" marL="0">
@@ -20497,7 +20497,7 @@
                 <a:ea typeface="Courier New" pitchFamily="34" charset="-122"/>
                 <a:cs typeface="Courier New" pitchFamily="34" charset="-120"/>
               </a:rPr>
-              <a:t>test_cbom_generation (test_navigator.TestCryptoAgilityCopilot.test_cbom_generation) .................. ok
+              <a:t>test_cbom_generation (test_navigator.TestCryptoAgilityNavigator.test_cbom_generation) .................. ok
 </a:t>
             </a:r>
             <a:pPr indent="0" marL="0">
@@ -20515,7 +20515,7 @@
                 <a:ea typeface="Courier New" pitchFamily="34" charset="-122"/>
                 <a:cs typeface="Courier New" pitchFamily="34" charset="-120"/>
               </a:rPr>
-              <a:t>test_context_noise_suppression (test_navigator.TestCryptoAgilityCopilot.test_context_noise_suppression) ok
+              <a:t>test_context_noise_suppression (test_navigator.TestCryptoAgilityNavigator.test_context_noise_suppression) ok
 </a:t>
             </a:r>
             <a:pPr indent="0" marL="0">
@@ -20533,7 +20533,7 @@
                 <a:ea typeface="Courier New" pitchFamily="34" charset="-122"/>
                 <a:cs typeface="Courier New" pitchFamily="34" charset="-120"/>
               </a:rPr>
-              <a:t>test_discovery_engine (test_navigator.TestCryptoAgilityCopilot.test_discovery_engine) ................ ok
+              <a:t>test_discovery_engine (test_navigator.TestCryptoAgilityNavigator.test_discovery_engine) ................ ok
 </a:t>
             </a:r>
             <a:pPr indent="0" marL="0">
@@ -20551,7 +20551,7 @@
                 <a:ea typeface="Courier New" pitchFamily="34" charset="-122"/>
                 <a:cs typeface="Courier New" pitchFamily="34" charset="-120"/>
               </a:rPr>
-              <a:t>test_scoring_and_mosca_inequality (test_navigator.TestCryptoAgilityCopilot.test_scoring_and_mosca) ... ok
+              <a:t>test_scoring_and_mosca_inequality (test_navigator.TestCryptoAgilityNavigator.test_scoring_and_mosca) ... ok
 </a:t>
             </a:r>
             <a:pPr indent="0" marL="0">
@@ -20569,7 +20569,7 @@
                 <a:ea typeface="Courier New" pitchFamily="34" charset="-122"/>
                 <a:cs typeface="Courier New" pitchFamily="34" charset="-120"/>
               </a:rPr>
-              <a:t>test_semantic_binding_discrimination (test_navigator.TestCryptoAgilityCopilot.test_semantic_binding) . ok
+              <a:t>test_semantic_binding_discrimination (test_navigator.TestCryptoAgilityNavigator.test_semantic_binding) . ok
 </a:t>
             </a:r>
             <a:pPr indent="0" marL="0">
@@ -32476,7 +32476,7 @@
                 <a:ea typeface="Arial" pitchFamily="34" charset="-122"/>
                 <a:cs typeface="Arial" pitchFamily="34" charset="-120"/>
               </a:rPr>
-              <a:t>COPILOT SOLUTION:</a:t>
+              <a:t>NAVIGATOR SOLUTION:</a:t>
             </a:r>
             <a:endParaRPr lang="en-US" sz="800" dirty="0"/>
           </a:p>
@@ -32702,7 +32702,7 @@
                 <a:ea typeface="Arial" pitchFamily="34" charset="-122"/>
                 <a:cs typeface="Arial" pitchFamily="34" charset="-120"/>
               </a:rPr>
-              <a:t>COPILOT SOLUTION:</a:t>
+              <a:t>NAVIGATOR SOLUTION:</a:t>
             </a:r>
             <a:endParaRPr lang="en-US" sz="800" dirty="0"/>
           </a:p>
@@ -32928,7 +32928,7 @@
                 <a:ea typeface="Arial" pitchFamily="34" charset="-122"/>
                 <a:cs typeface="Arial" pitchFamily="34" charset="-120"/>
               </a:rPr>
-              <a:t>COPILOT SOLUTION:</a:t>
+              <a:t>NAVIGATOR SOLUTION:</a:t>
             </a:r>
             <a:endParaRPr lang="en-US" sz="800" dirty="0"/>
           </a:p>

</xml_diff>